<commit_message>
Update One-Hot & Dummy Variable Encoding presentation file
</commit_message>
<xml_diff>
--- a/My Note and Practice/Text to Numerical Data Conversion/Categorical(Text to Numeric) data conversion-CTtN/Nominal Data/CTNtN1. One-Hot & Dummy Variable Encoding/One-Hot & Dummy Variable Encoding.pptx
+++ b/My Note and Practice/Text to Numerical Data Conversion/Categorical(Text to Numeric) data conversion-CTtN/Nominal Data/CTNtN1. One-Hot & Dummy Variable Encoding/One-Hot & Dummy Variable Encoding.pptx
@@ -5,21 +5,23 @@
     <p:sldMasterId id="2147483648" r:id="rId1"/>
   </p:sldMasterIdLst>
   <p:sldIdLst>
-    <p:sldId id="317" r:id="rId2"/>
-    <p:sldId id="318" r:id="rId3"/>
-    <p:sldId id="319" r:id="rId4"/>
-    <p:sldId id="320" r:id="rId5"/>
-    <p:sldId id="321" r:id="rId6"/>
-    <p:sldId id="322" r:id="rId7"/>
-    <p:sldId id="323" r:id="rId8"/>
-    <p:sldId id="324" r:id="rId9"/>
-    <p:sldId id="325" r:id="rId10"/>
-    <p:sldId id="326" r:id="rId11"/>
-    <p:sldId id="327" r:id="rId12"/>
-    <p:sldId id="328" r:id="rId13"/>
-    <p:sldId id="329" r:id="rId14"/>
-    <p:sldId id="330" r:id="rId15"/>
-    <p:sldId id="332" r:id="rId16"/>
+    <p:sldId id="333" r:id="rId2"/>
+    <p:sldId id="317" r:id="rId3"/>
+    <p:sldId id="318" r:id="rId4"/>
+    <p:sldId id="319" r:id="rId5"/>
+    <p:sldId id="320" r:id="rId6"/>
+    <p:sldId id="321" r:id="rId7"/>
+    <p:sldId id="322" r:id="rId8"/>
+    <p:sldId id="323" r:id="rId9"/>
+    <p:sldId id="324" r:id="rId10"/>
+    <p:sldId id="325" r:id="rId11"/>
+    <p:sldId id="326" r:id="rId12"/>
+    <p:sldId id="327" r:id="rId13"/>
+    <p:sldId id="334" r:id="rId14"/>
+    <p:sldId id="328" r:id="rId15"/>
+    <p:sldId id="329" r:id="rId16"/>
+    <p:sldId id="330" r:id="rId17"/>
+    <p:sldId id="332" r:id="rId18"/>
   </p:sldIdLst>
   <p:sldSz cx="12192000" cy="6858000"/>
   <p:notesSz cx="6858000" cy="9144000"/>
@@ -284,7 +286,7 @@
           <a:p>
             <a:fld id="{D6171EE1-2692-479A-A6A6-950CA86052A8}" type="datetimeFigureOut">
               <a:rPr lang="en-US" smtClean="0"/>
-              <a:t>11/16/2025</a:t>
+              <a:t>11/19/2025</a:t>
             </a:fld>
             <a:endParaRPr lang="en-US"/>
           </a:p>
@@ -482,7 +484,7 @@
           <a:p>
             <a:fld id="{D6171EE1-2692-479A-A6A6-950CA86052A8}" type="datetimeFigureOut">
               <a:rPr lang="en-US" smtClean="0"/>
-              <a:t>11/16/2025</a:t>
+              <a:t>11/19/2025</a:t>
             </a:fld>
             <a:endParaRPr lang="en-US"/>
           </a:p>
@@ -690,7 +692,7 @@
           <a:p>
             <a:fld id="{D6171EE1-2692-479A-A6A6-950CA86052A8}" type="datetimeFigureOut">
               <a:rPr lang="en-US" smtClean="0"/>
-              <a:t>11/16/2025</a:t>
+              <a:t>11/19/2025</a:t>
             </a:fld>
             <a:endParaRPr lang="en-US"/>
           </a:p>
@@ -888,7 +890,7 @@
           <a:p>
             <a:fld id="{D6171EE1-2692-479A-A6A6-950CA86052A8}" type="datetimeFigureOut">
               <a:rPr lang="en-US" smtClean="0"/>
-              <a:t>11/16/2025</a:t>
+              <a:t>11/19/2025</a:t>
             </a:fld>
             <a:endParaRPr lang="en-US"/>
           </a:p>
@@ -1163,7 +1165,7 @@
           <a:p>
             <a:fld id="{D6171EE1-2692-479A-A6A6-950CA86052A8}" type="datetimeFigureOut">
               <a:rPr lang="en-US" smtClean="0"/>
-              <a:t>11/16/2025</a:t>
+              <a:t>11/19/2025</a:t>
             </a:fld>
             <a:endParaRPr lang="en-US"/>
           </a:p>
@@ -1428,7 +1430,7 @@
           <a:p>
             <a:fld id="{D6171EE1-2692-479A-A6A6-950CA86052A8}" type="datetimeFigureOut">
               <a:rPr lang="en-US" smtClean="0"/>
-              <a:t>11/16/2025</a:t>
+              <a:t>11/19/2025</a:t>
             </a:fld>
             <a:endParaRPr lang="en-US"/>
           </a:p>
@@ -1840,7 +1842,7 @@
           <a:p>
             <a:fld id="{D6171EE1-2692-479A-A6A6-950CA86052A8}" type="datetimeFigureOut">
               <a:rPr lang="en-US" smtClean="0"/>
-              <a:t>11/16/2025</a:t>
+              <a:t>11/19/2025</a:t>
             </a:fld>
             <a:endParaRPr lang="en-US"/>
           </a:p>
@@ -1981,7 +1983,7 @@
           <a:p>
             <a:fld id="{D6171EE1-2692-479A-A6A6-950CA86052A8}" type="datetimeFigureOut">
               <a:rPr lang="en-US" smtClean="0"/>
-              <a:t>11/16/2025</a:t>
+              <a:t>11/19/2025</a:t>
             </a:fld>
             <a:endParaRPr lang="en-US"/>
           </a:p>
@@ -2094,7 +2096,7 @@
           <a:p>
             <a:fld id="{D6171EE1-2692-479A-A6A6-950CA86052A8}" type="datetimeFigureOut">
               <a:rPr lang="en-US" smtClean="0"/>
-              <a:t>11/16/2025</a:t>
+              <a:t>11/19/2025</a:t>
             </a:fld>
             <a:endParaRPr lang="en-US"/>
           </a:p>
@@ -2405,7 +2407,7 @@
           <a:p>
             <a:fld id="{D6171EE1-2692-479A-A6A6-950CA86052A8}" type="datetimeFigureOut">
               <a:rPr lang="en-US" smtClean="0"/>
-              <a:t>11/16/2025</a:t>
+              <a:t>11/19/2025</a:t>
             </a:fld>
             <a:endParaRPr lang="en-US"/>
           </a:p>
@@ -2693,7 +2695,7 @@
           <a:p>
             <a:fld id="{D6171EE1-2692-479A-A6A6-950CA86052A8}" type="datetimeFigureOut">
               <a:rPr lang="en-US" smtClean="0"/>
-              <a:t>11/16/2025</a:t>
+              <a:t>11/19/2025</a:t>
             </a:fld>
             <a:endParaRPr lang="en-US"/>
           </a:p>
@@ -2934,7 +2936,7 @@
           <a:p>
             <a:fld id="{D6171EE1-2692-479A-A6A6-950CA86052A8}" type="datetimeFigureOut">
               <a:rPr lang="en-US" smtClean="0"/>
-              <a:t>11/16/2025</a:t>
+              <a:t>11/19/2025</a:t>
             </a:fld>
             <a:endParaRPr lang="en-US"/>
           </a:p>
@@ -3339,13 +3341,7 @@
   <p:cSld>
     <p:spTree>
       <p:nvGrpSpPr>
-        <p:cNvPr id="1" name="">
-          <a:extLst>
-            <a:ext uri="{FF2B5EF4-FFF2-40B4-BE49-F238E27FC236}">
-              <a16:creationId xmlns:a16="http://schemas.microsoft.com/office/drawing/2014/main" id="{8CA822CF-61E7-D4A4-E048-D296A45421F7}"/>
-            </a:ext>
-          </a:extLst>
-        </p:cNvPr>
+        <p:cNvPr id="1" name=""/>
         <p:cNvGrpSpPr/>
         <p:nvPr/>
       </p:nvGrpSpPr>
@@ -3362,61 +3358,50 @@
           <p:cNvPr id="2" name="Title 1">
             <a:extLst>
               <a:ext uri="{FF2B5EF4-FFF2-40B4-BE49-F238E27FC236}">
-                <a16:creationId xmlns:a16="http://schemas.microsoft.com/office/drawing/2014/main" id="{B0117384-56C5-24B5-624E-767F3168840B}"/>
-              </a:ext>
-            </a:extLst>
-          </p:cNvPr>
-          <p:cNvSpPr>
-            <a:spLocks noGrp="1"/>
-          </p:cNvSpPr>
-          <p:nvPr>
-            <p:ph type="title"/>
-          </p:nvPr>
-        </p:nvSpPr>
-        <p:spPr>
-          <a:xfrm>
-            <a:off x="838200" y="365125"/>
-            <a:ext cx="10515600" cy="640080"/>
-          </a:xfrm>
-        </p:spPr>
+                <a16:creationId xmlns:a16="http://schemas.microsoft.com/office/drawing/2014/main" id="{533DDACD-A353-C210-D9E6-F96FA09F62B5}"/>
+              </a:ext>
+            </a:extLst>
+          </p:cNvPr>
+          <p:cNvSpPr>
+            <a:spLocks noGrp="1"/>
+          </p:cNvSpPr>
+          <p:nvPr>
+            <p:ph type="ctrTitle"/>
+          </p:nvPr>
+        </p:nvSpPr>
+        <p:spPr/>
         <p:txBody>
           <a:bodyPr>
             <a:normAutofit/>
           </a:bodyPr>
           <a:lstStyle/>
           <a:p>
-            <a:pPr algn="ctr"/>
-            <a:r>
-              <a:rPr lang="en-US" sz="3600" dirty="0">
+            <a:r>
+              <a:rPr lang="en-US" sz="7000" dirty="0">
                 <a:latin typeface="Bebas Neue" panose="020B0606020202050201" pitchFamily="34" charset="0"/>
               </a:rPr>
-              <a:t>One-hot Encoding</a:t>
-            </a:r>
-          </a:p>
-        </p:txBody>
-      </p:sp>
-      <p:sp>
-        <p:nvSpPr>
-          <p:cNvPr id="3" name="Content Placeholder 2">
-            <a:extLst>
-              <a:ext uri="{FF2B5EF4-FFF2-40B4-BE49-F238E27FC236}">
-                <a16:creationId xmlns:a16="http://schemas.microsoft.com/office/drawing/2014/main" id="{F56ACDEB-9BE6-9E8C-F3F3-47CC1816FE9C}"/>
-              </a:ext>
-            </a:extLst>
-          </p:cNvPr>
-          <p:cNvSpPr>
-            <a:spLocks noGrp="1"/>
-          </p:cNvSpPr>
-          <p:nvPr>
-            <p:ph idx="1"/>
-          </p:nvPr>
-        </p:nvSpPr>
-        <p:spPr>
-          <a:xfrm>
-            <a:off x="838200" y="1091381"/>
-            <a:ext cx="10515600" cy="5085582"/>
-          </a:xfrm>
-        </p:spPr>
+              <a:t>One-Hot Encoding in Machine Learning</a:t>
+            </a:r>
+          </a:p>
+        </p:txBody>
+      </p:sp>
+      <p:sp>
+        <p:nvSpPr>
+          <p:cNvPr id="3" name="Subtitle 2">
+            <a:extLst>
+              <a:ext uri="{FF2B5EF4-FFF2-40B4-BE49-F238E27FC236}">
+                <a16:creationId xmlns:a16="http://schemas.microsoft.com/office/drawing/2014/main" id="{BB70C6DD-1FFB-8E79-FC8A-48FC718E9552}"/>
+              </a:ext>
+            </a:extLst>
+          </p:cNvPr>
+          <p:cNvSpPr>
+            <a:spLocks noGrp="1"/>
+          </p:cNvSpPr>
+          <p:nvPr>
+            <p:ph type="subTitle" idx="1"/>
+          </p:nvPr>
+        </p:nvSpPr>
+        <p:spPr/>
         <p:txBody>
           <a:bodyPr>
             <a:normAutofit/>
@@ -3424,86 +3409,20 @@
           <a:lstStyle/>
           <a:p>
             <a:r>
-              <a:rPr lang="en-US" sz="2400" b="1" dirty="0">
+              <a:rPr lang="en-US" sz="3200" dirty="0">
                 <a:latin typeface="Open Sans" pitchFamily="2" charset="0"/>
                 <a:ea typeface="Open Sans" pitchFamily="2" charset="0"/>
                 <a:cs typeface="Open Sans" pitchFamily="2" charset="0"/>
               </a:rPr>
-              <a:t>One Hot Encoding</a:t>
-            </a:r>
-            <a:r>
-              <a:rPr lang="en-US" sz="2400" dirty="0">
-                <a:latin typeface="Open Sans" pitchFamily="2" charset="0"/>
-                <a:ea typeface="Open Sans" pitchFamily="2" charset="0"/>
-                <a:cs typeface="Open Sans" pitchFamily="2" charset="0"/>
-              </a:rPr>
-              <a:t> is a </a:t>
-            </a:r>
-            <a:r>
-              <a:rPr lang="en-US" sz="2400" b="1" i="1" dirty="0">
-                <a:latin typeface="Open Sans" pitchFamily="2" charset="0"/>
-                <a:ea typeface="Open Sans" pitchFamily="2" charset="0"/>
-                <a:cs typeface="Open Sans" pitchFamily="2" charset="0"/>
-              </a:rPr>
-              <a:t>method for converting categorical variables into a binary format.</a:t>
-            </a:r>
-          </a:p>
-          <a:p>
-            <a:r>
-              <a:rPr lang="en-US" sz="2400" dirty="0">
-                <a:latin typeface="Open Sans" pitchFamily="2" charset="0"/>
-                <a:ea typeface="Open Sans" pitchFamily="2" charset="0"/>
-                <a:cs typeface="Open Sans" pitchFamily="2" charset="0"/>
-              </a:rPr>
-              <a:t>It creates new columns for each category where </a:t>
-            </a:r>
-            <a:r>
-              <a:rPr lang="en-US" sz="2400" b="1" dirty="0">
-                <a:latin typeface="Open Sans" pitchFamily="2" charset="0"/>
-                <a:ea typeface="Open Sans" pitchFamily="2" charset="0"/>
-                <a:cs typeface="Open Sans" pitchFamily="2" charset="0"/>
-              </a:rPr>
-              <a:t>1</a:t>
-            </a:r>
-            <a:r>
-              <a:rPr lang="en-US" sz="2400" dirty="0">
-                <a:latin typeface="Open Sans" pitchFamily="2" charset="0"/>
-                <a:ea typeface="Open Sans" pitchFamily="2" charset="0"/>
-                <a:cs typeface="Open Sans" pitchFamily="2" charset="0"/>
-              </a:rPr>
-              <a:t> means the category is present and </a:t>
-            </a:r>
-            <a:r>
-              <a:rPr lang="en-US" sz="2400" b="1" dirty="0">
-                <a:latin typeface="Open Sans" pitchFamily="2" charset="0"/>
-                <a:ea typeface="Open Sans" pitchFamily="2" charset="0"/>
-                <a:cs typeface="Open Sans" pitchFamily="2" charset="0"/>
-              </a:rPr>
-              <a:t>0</a:t>
-            </a:r>
-            <a:r>
-              <a:rPr lang="en-US" sz="2400" dirty="0">
-                <a:latin typeface="Open Sans" pitchFamily="2" charset="0"/>
-                <a:ea typeface="Open Sans" pitchFamily="2" charset="0"/>
-                <a:cs typeface="Open Sans" pitchFamily="2" charset="0"/>
-              </a:rPr>
-              <a:t> means it is not. The primary purpose of One Hot Encoding is to ensure that categorical data can be effectively used in machine learning models.</a:t>
-            </a:r>
-            <a:endParaRPr lang="en-US" sz="2400" b="1" dirty="0">
-              <a:solidFill>
-                <a:srgbClr val="FF0000"/>
-              </a:solidFill>
-              <a:latin typeface="Open Sans" pitchFamily="2" charset="0"/>
-              <a:ea typeface="Open Sans" pitchFamily="2" charset="0"/>
-              <a:cs typeface="Open Sans" pitchFamily="2" charset="0"/>
-            </a:endParaRPr>
+              <a:t>A Technique to Convert Categories into Binary Feature Vectors</a:t>
+            </a:r>
           </a:p>
         </p:txBody>
       </p:sp>
     </p:spTree>
     <p:extLst>
       <p:ext uri="{BB962C8B-B14F-4D97-AF65-F5344CB8AC3E}">
-        <p14:creationId xmlns:p14="http://schemas.microsoft.com/office/powerpoint/2010/main" val="3297150731"/>
+        <p14:creationId xmlns:p14="http://schemas.microsoft.com/office/powerpoint/2010/main" val="2398648148"/>
       </p:ext>
     </p:extLst>
   </p:cSld>
@@ -3602,6 +3521,164 @@
           </a:bodyPr>
           <a:lstStyle/>
           <a:p>
+            <a:pPr algn="just" fontAlgn="base"/>
+            <a:r>
+              <a:rPr lang="en-US" sz="2400" dirty="0">
+                <a:latin typeface="Open Sans" pitchFamily="2" charset="0"/>
+                <a:ea typeface="Open Sans" pitchFamily="2" charset="0"/>
+                <a:cs typeface="Open Sans" pitchFamily="2" charset="0"/>
+              </a:rPr>
+              <a:t>While One Hot Encoding is a popular choice for handling categorical data there are several alternatives that may be more suitable depending on the context:</a:t>
+            </a:r>
+          </a:p>
+          <a:p>
+            <a:pPr marL="342900" indent="-342900" algn="just" fontAlgn="base">
+              <a:buFont typeface="+mj-lt"/>
+              <a:buAutoNum type="arabicPeriod"/>
+            </a:pPr>
+            <a:r>
+              <a:rPr lang="en-US" sz="2400" b="1" dirty="0">
+                <a:latin typeface="Open Sans" pitchFamily="2" charset="0"/>
+                <a:ea typeface="Open Sans" pitchFamily="2" charset="0"/>
+                <a:cs typeface="Open Sans" pitchFamily="2" charset="0"/>
+              </a:rPr>
+              <a:t>Label Encoding</a:t>
+            </a:r>
+            <a:r>
+              <a:rPr lang="en-US" sz="2400" dirty="0">
+                <a:latin typeface="Open Sans" pitchFamily="2" charset="0"/>
+                <a:ea typeface="Open Sans" pitchFamily="2" charset="0"/>
+                <a:cs typeface="Open Sans" pitchFamily="2" charset="0"/>
+              </a:rPr>
+              <a:t>: In cases where categorical variables have a natural order (e.g., "Low," "Medium," "High") label encoding can be a better option. This method assigns a unique integer to each category without introducing the same risks of hierarchy misinterpretation as with nominal data.</a:t>
+            </a:r>
+          </a:p>
+          <a:p>
+            <a:pPr marL="342900" indent="-342900" algn="just" fontAlgn="base">
+              <a:buFont typeface="+mj-lt"/>
+              <a:buAutoNum type="arabicPeriod"/>
+            </a:pPr>
+            <a:r>
+              <a:rPr lang="en-US" sz="2400" b="1" dirty="0">
+                <a:latin typeface="Open Sans" pitchFamily="2" charset="0"/>
+                <a:ea typeface="Open Sans" pitchFamily="2" charset="0"/>
+                <a:cs typeface="Open Sans" pitchFamily="2" charset="0"/>
+              </a:rPr>
+              <a:t>Binary Encoding</a:t>
+            </a:r>
+            <a:r>
+              <a:rPr lang="en-US" sz="2400" dirty="0">
+                <a:latin typeface="Open Sans" pitchFamily="2" charset="0"/>
+                <a:ea typeface="Open Sans" pitchFamily="2" charset="0"/>
+                <a:cs typeface="Open Sans" pitchFamily="2" charset="0"/>
+              </a:rPr>
+              <a:t>: This technique combines the benefits of One Hot Encoding and label encoding. It converts categories into binary numbers and then creates binary columns. This method can reduce dimensionality while preserving information.</a:t>
+            </a:r>
+          </a:p>
+        </p:txBody>
+      </p:sp>
+    </p:spTree>
+    <p:extLst>
+      <p:ext uri="{BB962C8B-B14F-4D97-AF65-F5344CB8AC3E}">
+        <p14:creationId xmlns:p14="http://schemas.microsoft.com/office/powerpoint/2010/main" val="2595340338"/>
+      </p:ext>
+    </p:extLst>
+  </p:cSld>
+  <p:clrMapOvr>
+    <a:masterClrMapping/>
+  </p:clrMapOvr>
+</p:sld>
+</file>
+
+<file path=ppt/slides/slide11.xml><?xml version="1.0" encoding="utf-8"?>
+<p:sld xmlns:a="http://schemas.openxmlformats.org/drawingml/2006/main" xmlns:r="http://schemas.openxmlformats.org/officeDocument/2006/relationships" xmlns:p="http://schemas.openxmlformats.org/presentationml/2006/main">
+  <p:cSld>
+    <p:spTree>
+      <p:nvGrpSpPr>
+        <p:cNvPr id="1" name="">
+          <a:extLst>
+            <a:ext uri="{FF2B5EF4-FFF2-40B4-BE49-F238E27FC236}">
+              <a16:creationId xmlns:a16="http://schemas.microsoft.com/office/drawing/2014/main" id="{8CA822CF-61E7-D4A4-E048-D296A45421F7}"/>
+            </a:ext>
+          </a:extLst>
+        </p:cNvPr>
+        <p:cNvGrpSpPr/>
+        <p:nvPr/>
+      </p:nvGrpSpPr>
+      <p:grpSpPr>
+        <a:xfrm>
+          <a:off x="0" y="0"/>
+          <a:ext cx="0" cy="0"/>
+          <a:chOff x="0" y="0"/>
+          <a:chExt cx="0" cy="0"/>
+        </a:xfrm>
+      </p:grpSpPr>
+      <p:sp>
+        <p:nvSpPr>
+          <p:cNvPr id="2" name="Title 1">
+            <a:extLst>
+              <a:ext uri="{FF2B5EF4-FFF2-40B4-BE49-F238E27FC236}">
+                <a16:creationId xmlns:a16="http://schemas.microsoft.com/office/drawing/2014/main" id="{B0117384-56C5-24B5-624E-767F3168840B}"/>
+              </a:ext>
+            </a:extLst>
+          </p:cNvPr>
+          <p:cNvSpPr>
+            <a:spLocks noGrp="1"/>
+          </p:cNvSpPr>
+          <p:nvPr>
+            <p:ph type="title"/>
+          </p:nvPr>
+        </p:nvSpPr>
+        <p:spPr>
+          <a:xfrm>
+            <a:off x="838200" y="365125"/>
+            <a:ext cx="10515600" cy="640080"/>
+          </a:xfrm>
+        </p:spPr>
+        <p:txBody>
+          <a:bodyPr>
+            <a:normAutofit/>
+          </a:bodyPr>
+          <a:lstStyle/>
+          <a:p>
+            <a:pPr algn="ctr" fontAlgn="base"/>
+            <a:r>
+              <a:rPr lang="en-US" sz="3600" dirty="0">
+                <a:latin typeface="Bebas Neue" panose="020B0606020202050201" pitchFamily="34" charset="0"/>
+              </a:rPr>
+              <a:t>Alternatives to One Hot Encoding</a:t>
+            </a:r>
+          </a:p>
+        </p:txBody>
+      </p:sp>
+      <p:sp>
+        <p:nvSpPr>
+          <p:cNvPr id="3" name="Content Placeholder 2">
+            <a:extLst>
+              <a:ext uri="{FF2B5EF4-FFF2-40B4-BE49-F238E27FC236}">
+                <a16:creationId xmlns:a16="http://schemas.microsoft.com/office/drawing/2014/main" id="{F56ACDEB-9BE6-9E8C-F3F3-47CC1816FE9C}"/>
+              </a:ext>
+            </a:extLst>
+          </p:cNvPr>
+          <p:cNvSpPr>
+            <a:spLocks noGrp="1"/>
+          </p:cNvSpPr>
+          <p:nvPr>
+            <p:ph idx="1"/>
+          </p:nvPr>
+        </p:nvSpPr>
+        <p:spPr>
+          <a:xfrm>
+            <a:off x="838200" y="1091381"/>
+            <a:ext cx="10515600" cy="5085582"/>
+          </a:xfrm>
+        </p:spPr>
+        <p:txBody>
+          <a:bodyPr>
+            <a:normAutofit/>
+          </a:bodyPr>
+          <a:lstStyle/>
+          <a:p>
             <a:pPr marL="457200" indent="-457200" algn="just" fontAlgn="base">
               <a:buFont typeface="+mj-lt"/>
               <a:buAutoNum type="arabicPeriod" startAt="3"/>
@@ -3638,7 +3715,7 @@
 </p:sld>
 </file>
 
-<file path=ppt/slides/slide11.xml><?xml version="1.0" encoding="utf-8"?>
+<file path=ppt/slides/slide12.xml><?xml version="1.0" encoding="utf-8"?>
 <p:sld xmlns:a="http://schemas.openxmlformats.org/drawingml/2006/main" xmlns:r="http://schemas.openxmlformats.org/officeDocument/2006/relationships" xmlns:p="http://schemas.openxmlformats.org/presentationml/2006/main">
   <p:cSld>
     <p:spTree>
@@ -4228,7 +4305,103 @@
 </p:sld>
 </file>
 
-<file path=ppt/slides/slide12.xml><?xml version="1.0" encoding="utf-8"?>
+<file path=ppt/slides/slide13.xml><?xml version="1.0" encoding="utf-8"?>
+<p:sld xmlns:a="http://schemas.openxmlformats.org/drawingml/2006/main" xmlns:r="http://schemas.openxmlformats.org/officeDocument/2006/relationships" xmlns:p="http://schemas.openxmlformats.org/presentationml/2006/main">
+  <p:cSld>
+    <p:spTree>
+      <p:nvGrpSpPr>
+        <p:cNvPr id="1" name=""/>
+        <p:cNvGrpSpPr/>
+        <p:nvPr/>
+      </p:nvGrpSpPr>
+      <p:grpSpPr>
+        <a:xfrm>
+          <a:off x="0" y="0"/>
+          <a:ext cx="0" cy="0"/>
+          <a:chOff x="0" y="0"/>
+          <a:chExt cx="0" cy="0"/>
+        </a:xfrm>
+      </p:grpSpPr>
+      <p:sp>
+        <p:nvSpPr>
+          <p:cNvPr id="2" name="Title 1">
+            <a:extLst>
+              <a:ext uri="{FF2B5EF4-FFF2-40B4-BE49-F238E27FC236}">
+                <a16:creationId xmlns:a16="http://schemas.microsoft.com/office/drawing/2014/main" id="{9AC72DB9-7D98-3D76-0BF3-A27B9B04417D}"/>
+              </a:ext>
+            </a:extLst>
+          </p:cNvPr>
+          <p:cNvSpPr>
+            <a:spLocks noGrp="1"/>
+          </p:cNvSpPr>
+          <p:nvPr>
+            <p:ph type="ctrTitle"/>
+          </p:nvPr>
+        </p:nvSpPr>
+        <p:spPr/>
+        <p:txBody>
+          <a:bodyPr>
+            <a:normAutofit/>
+          </a:bodyPr>
+          <a:lstStyle/>
+          <a:p>
+            <a:r>
+              <a:rPr lang="en-US" sz="7000" dirty="0">
+                <a:latin typeface="Bebas Neue" panose="020B0606020202050201" pitchFamily="34" charset="0"/>
+              </a:rPr>
+              <a:t>Dummy Variable Encoding in Machine Learning</a:t>
+            </a:r>
+          </a:p>
+        </p:txBody>
+      </p:sp>
+      <p:sp>
+        <p:nvSpPr>
+          <p:cNvPr id="3" name="Subtitle 2">
+            <a:extLst>
+              <a:ext uri="{FF2B5EF4-FFF2-40B4-BE49-F238E27FC236}">
+                <a16:creationId xmlns:a16="http://schemas.microsoft.com/office/drawing/2014/main" id="{7A7B30B6-676C-A88B-1296-7AA04CFEB5D6}"/>
+              </a:ext>
+            </a:extLst>
+          </p:cNvPr>
+          <p:cNvSpPr>
+            <a:spLocks noGrp="1"/>
+          </p:cNvSpPr>
+          <p:nvPr>
+            <p:ph type="subTitle" idx="1"/>
+          </p:nvPr>
+        </p:nvSpPr>
+        <p:spPr/>
+        <p:txBody>
+          <a:bodyPr>
+            <a:normAutofit/>
+          </a:bodyPr>
+          <a:lstStyle/>
+          <a:p>
+            <a:r>
+              <a:rPr lang="en-US" sz="3200" dirty="0">
+                <a:latin typeface="Open Sans" pitchFamily="2" charset="0"/>
+                <a:ea typeface="Open Sans" pitchFamily="2" charset="0"/>
+                <a:cs typeface="Open Sans" pitchFamily="2" charset="0"/>
+              </a:rPr>
+              <a:t>A Technique to Represent Categories Using Binary Variables Without Redundancy</a:t>
+            </a:r>
+          </a:p>
+        </p:txBody>
+      </p:sp>
+    </p:spTree>
+    <p:extLst>
+      <p:ext uri="{BB962C8B-B14F-4D97-AF65-F5344CB8AC3E}">
+        <p14:creationId xmlns:p14="http://schemas.microsoft.com/office/powerpoint/2010/main" val="3241764910"/>
+      </p:ext>
+    </p:extLst>
+  </p:cSld>
+  <p:clrMapOvr>
+    <a:masterClrMapping/>
+  </p:clrMapOvr>
+</p:sld>
+</file>
+
+<file path=ppt/slides/slide14.xml><?xml version="1.0" encoding="utf-8"?>
 <p:sld xmlns:a="http://schemas.openxmlformats.org/drawingml/2006/main" xmlns:r="http://schemas.openxmlformats.org/officeDocument/2006/relationships" xmlns:p="http://schemas.openxmlformats.org/presentationml/2006/main">
   <p:cSld>
     <p:spTree>
@@ -5437,7 +5610,7 @@
 </p:sld>
 </file>
 
-<file path=ppt/slides/slide13.xml><?xml version="1.0" encoding="utf-8"?>
+<file path=ppt/slides/slide15.xml><?xml version="1.0" encoding="utf-8"?>
 <p:sld xmlns:a="http://schemas.openxmlformats.org/drawingml/2006/main" xmlns:r="http://schemas.openxmlformats.org/officeDocument/2006/relationships" xmlns:p="http://schemas.openxmlformats.org/presentationml/2006/main">
   <p:cSld>
     <p:spTree>
@@ -5550,7 +5723,7 @@
 </p:sld>
 </file>
 
-<file path=ppt/slides/slide14.xml><?xml version="1.0" encoding="utf-8"?>
+<file path=ppt/slides/slide16.xml><?xml version="1.0" encoding="utf-8"?>
 <p:sld xmlns:a="http://schemas.openxmlformats.org/drawingml/2006/main" xmlns:r="http://schemas.openxmlformats.org/officeDocument/2006/relationships" xmlns:p="http://schemas.openxmlformats.org/presentationml/2006/main">
   <p:cSld>
     <p:spTree>
@@ -6027,7 +6200,7 @@
 </p:sld>
 </file>
 
-<file path=ppt/slides/slide15.xml><?xml version="1.0" encoding="utf-8"?>
+<file path=ppt/slides/slide17.xml><?xml version="1.0" encoding="utf-8"?>
 <p:sld xmlns:a="http://schemas.openxmlformats.org/drawingml/2006/main" xmlns:r="http://schemas.openxmlformats.org/officeDocument/2006/relationships" xmlns:p="http://schemas.openxmlformats.org/presentationml/2006/main">
   <p:cSld>
     <p:spTree>
@@ -6200,7 +6373,7 @@
               <a:rPr lang="en-US" sz="3600" dirty="0">
                 <a:latin typeface="Bebas Neue" panose="020B0606020202050201" pitchFamily="34" charset="0"/>
               </a:rPr>
-              <a:t>Importance of One Hot Encoding</a:t>
+              <a:t>One-hot Encoding</a:t>
             </a:r>
           </a:p>
         </p:txBody>
@@ -6234,25 +6407,46 @@
           <a:lstStyle/>
           <a:p>
             <a:r>
+              <a:rPr lang="en-US" sz="2400" b="1" dirty="0">
+                <a:latin typeface="Open Sans" pitchFamily="2" charset="0"/>
+                <a:ea typeface="Open Sans" pitchFamily="2" charset="0"/>
+                <a:cs typeface="Open Sans" pitchFamily="2" charset="0"/>
+              </a:rPr>
+              <a:t>One Hot Encoding</a:t>
+            </a:r>
+            <a:r>
               <a:rPr lang="en-US" sz="2400" dirty="0">
                 <a:latin typeface="Open Sans" pitchFamily="2" charset="0"/>
                 <a:ea typeface="Open Sans" pitchFamily="2" charset="0"/>
                 <a:cs typeface="Open Sans" pitchFamily="2" charset="0"/>
               </a:rPr>
-              <a:t>We use one hot Encoding because:</a:t>
-            </a:r>
-          </a:p>
-          <a:p>
-            <a:pPr marL="457200" indent="-457200">
-              <a:buAutoNum type="arabicPeriod"/>
-            </a:pPr>
+              <a:t> is a </a:t>
+            </a:r>
+            <a:r>
+              <a:rPr lang="en-US" sz="2400" b="1" i="1" dirty="0">
+                <a:latin typeface="Open Sans" pitchFamily="2" charset="0"/>
+                <a:ea typeface="Open Sans" pitchFamily="2" charset="0"/>
+                <a:cs typeface="Open Sans" pitchFamily="2" charset="0"/>
+              </a:rPr>
+              <a:t>method for converting categorical variables into a binary format.</a:t>
+            </a:r>
+          </a:p>
+          <a:p>
+            <a:r>
+              <a:rPr lang="en-US" sz="2400" dirty="0">
+                <a:latin typeface="Open Sans" pitchFamily="2" charset="0"/>
+                <a:ea typeface="Open Sans" pitchFamily="2" charset="0"/>
+                <a:cs typeface="Open Sans" pitchFamily="2" charset="0"/>
+              </a:rPr>
+              <a:t>It creates new columns for each category where </a:t>
+            </a:r>
             <a:r>
               <a:rPr lang="en-US" sz="2400" b="1" dirty="0">
                 <a:latin typeface="Open Sans" pitchFamily="2" charset="0"/>
                 <a:ea typeface="Open Sans" pitchFamily="2" charset="0"/>
                 <a:cs typeface="Open Sans" pitchFamily="2" charset="0"/>
               </a:rPr>
-              <a:t>Eliminating Ordinality</a:t>
+              <a:t>1</a:t>
             </a:r>
             <a:r>
               <a:rPr lang="en-US" sz="2400" dirty="0">
@@ -6260,21 +6454,15 @@
                 <a:ea typeface="Open Sans" pitchFamily="2" charset="0"/>
                 <a:cs typeface="Open Sans" pitchFamily="2" charset="0"/>
               </a:rPr>
-              <a:t>: Many categorical variables have no inherent order (e.g., "Male" and "Female"). If we were to assign numerical values (e.g., Male = 0, Female = 1) the model might mistakenly interpret this as a ranking and lead to biased predictions. One Hot Encoding eliminates this risk by treating each category independently.</a:t>
-            </a:r>
-          </a:p>
-          <a:p>
-            <a:pPr marL="457200" indent="-457200">
-              <a:buFontTx/>
-              <a:buAutoNum type="arabicPeriod"/>
-            </a:pPr>
+              <a:t> means the category is present and </a:t>
+            </a:r>
             <a:r>
               <a:rPr lang="en-US" sz="2400" b="1" dirty="0">
                 <a:latin typeface="Open Sans" pitchFamily="2" charset="0"/>
                 <a:ea typeface="Open Sans" pitchFamily="2" charset="0"/>
                 <a:cs typeface="Open Sans" pitchFamily="2" charset="0"/>
               </a:rPr>
-              <a:t>Improving Model Performance</a:t>
+              <a:t>0</a:t>
             </a:r>
             <a:r>
               <a:rPr lang="en-US" sz="2400" dirty="0">
@@ -6282,15 +6470,23 @@
                 <a:ea typeface="Open Sans" pitchFamily="2" charset="0"/>
                 <a:cs typeface="Open Sans" pitchFamily="2" charset="0"/>
               </a:rPr>
-              <a:t>: By providing a more detailed representation of categorical variables. One Hot Encoding can help to improve the performance of machine learning models. It allows models to capture complex relationships within the data that might be missed if categorical variables were treated as single entities.</a:t>
-            </a:r>
+              <a:t> means it is not. The primary purpose of One Hot Encoding is to ensure that categorical data can be effectively used in machine learning models.</a:t>
+            </a:r>
+            <a:endParaRPr lang="en-US" sz="2400" b="1" dirty="0">
+              <a:solidFill>
+                <a:srgbClr val="FF0000"/>
+              </a:solidFill>
+              <a:latin typeface="Open Sans" pitchFamily="2" charset="0"/>
+              <a:ea typeface="Open Sans" pitchFamily="2" charset="0"/>
+              <a:cs typeface="Open Sans" pitchFamily="2" charset="0"/>
+            </a:endParaRPr>
           </a:p>
         </p:txBody>
       </p:sp>
     </p:spTree>
     <p:extLst>
       <p:ext uri="{BB962C8B-B14F-4D97-AF65-F5344CB8AC3E}">
-        <p14:creationId xmlns:p14="http://schemas.microsoft.com/office/powerpoint/2010/main" val="3460860206"/>
+        <p14:creationId xmlns:p14="http://schemas.microsoft.com/office/powerpoint/2010/main" val="3297150731"/>
       </p:ext>
     </p:extLst>
   </p:cSld>
@@ -6389,6 +6585,162 @@
           </a:bodyPr>
           <a:lstStyle/>
           <a:p>
+            <a:r>
+              <a:rPr lang="en-US" sz="2400" dirty="0">
+                <a:latin typeface="Open Sans" pitchFamily="2" charset="0"/>
+                <a:ea typeface="Open Sans" pitchFamily="2" charset="0"/>
+                <a:cs typeface="Open Sans" pitchFamily="2" charset="0"/>
+              </a:rPr>
+              <a:t>We use one hot Encoding because:</a:t>
+            </a:r>
+          </a:p>
+          <a:p>
+            <a:pPr marL="457200" indent="-457200">
+              <a:buAutoNum type="arabicPeriod"/>
+            </a:pPr>
+            <a:r>
+              <a:rPr lang="en-US" sz="2400" b="1" dirty="0">
+                <a:latin typeface="Open Sans" pitchFamily="2" charset="0"/>
+                <a:ea typeface="Open Sans" pitchFamily="2" charset="0"/>
+                <a:cs typeface="Open Sans" pitchFamily="2" charset="0"/>
+              </a:rPr>
+              <a:t>Eliminating Ordinality</a:t>
+            </a:r>
+            <a:r>
+              <a:rPr lang="en-US" sz="2400" dirty="0">
+                <a:latin typeface="Open Sans" pitchFamily="2" charset="0"/>
+                <a:ea typeface="Open Sans" pitchFamily="2" charset="0"/>
+                <a:cs typeface="Open Sans" pitchFamily="2" charset="0"/>
+              </a:rPr>
+              <a:t>: Many categorical variables have no inherent order (e.g., "Male" and "Female"). If we were to assign numerical values (e.g., Male = 0, Female = 1) the model might mistakenly interpret this as a ranking and lead to biased predictions. One Hot Encoding eliminates this risk by treating each category independently.</a:t>
+            </a:r>
+          </a:p>
+          <a:p>
+            <a:pPr marL="457200" indent="-457200">
+              <a:buFontTx/>
+              <a:buAutoNum type="arabicPeriod"/>
+            </a:pPr>
+            <a:r>
+              <a:rPr lang="en-US" sz="2400" b="1" dirty="0">
+                <a:latin typeface="Open Sans" pitchFamily="2" charset="0"/>
+                <a:ea typeface="Open Sans" pitchFamily="2" charset="0"/>
+                <a:cs typeface="Open Sans" pitchFamily="2" charset="0"/>
+              </a:rPr>
+              <a:t>Improving Model Performance</a:t>
+            </a:r>
+            <a:r>
+              <a:rPr lang="en-US" sz="2400" dirty="0">
+                <a:latin typeface="Open Sans" pitchFamily="2" charset="0"/>
+                <a:ea typeface="Open Sans" pitchFamily="2" charset="0"/>
+                <a:cs typeface="Open Sans" pitchFamily="2" charset="0"/>
+              </a:rPr>
+              <a:t>: By providing a more detailed representation of categorical variables. One Hot Encoding can help to improve the performance of machine learning models. It allows models to capture complex relationships within the data that might be missed if categorical variables were treated as single entities.</a:t>
+            </a:r>
+          </a:p>
+        </p:txBody>
+      </p:sp>
+    </p:spTree>
+    <p:extLst>
+      <p:ext uri="{BB962C8B-B14F-4D97-AF65-F5344CB8AC3E}">
+        <p14:creationId xmlns:p14="http://schemas.microsoft.com/office/powerpoint/2010/main" val="3460860206"/>
+      </p:ext>
+    </p:extLst>
+  </p:cSld>
+  <p:clrMapOvr>
+    <a:masterClrMapping/>
+  </p:clrMapOvr>
+</p:sld>
+</file>
+
+<file path=ppt/slides/slide4.xml><?xml version="1.0" encoding="utf-8"?>
+<p:sld xmlns:a="http://schemas.openxmlformats.org/drawingml/2006/main" xmlns:r="http://schemas.openxmlformats.org/officeDocument/2006/relationships" xmlns:p="http://schemas.openxmlformats.org/presentationml/2006/main">
+  <p:cSld>
+    <p:spTree>
+      <p:nvGrpSpPr>
+        <p:cNvPr id="1" name="">
+          <a:extLst>
+            <a:ext uri="{FF2B5EF4-FFF2-40B4-BE49-F238E27FC236}">
+              <a16:creationId xmlns:a16="http://schemas.microsoft.com/office/drawing/2014/main" id="{8CA822CF-61E7-D4A4-E048-D296A45421F7}"/>
+            </a:ext>
+          </a:extLst>
+        </p:cNvPr>
+        <p:cNvGrpSpPr/>
+        <p:nvPr/>
+      </p:nvGrpSpPr>
+      <p:grpSpPr>
+        <a:xfrm>
+          <a:off x="0" y="0"/>
+          <a:ext cx="0" cy="0"/>
+          <a:chOff x="0" y="0"/>
+          <a:chExt cx="0" cy="0"/>
+        </a:xfrm>
+      </p:grpSpPr>
+      <p:sp>
+        <p:nvSpPr>
+          <p:cNvPr id="2" name="Title 1">
+            <a:extLst>
+              <a:ext uri="{FF2B5EF4-FFF2-40B4-BE49-F238E27FC236}">
+                <a16:creationId xmlns:a16="http://schemas.microsoft.com/office/drawing/2014/main" id="{B0117384-56C5-24B5-624E-767F3168840B}"/>
+              </a:ext>
+            </a:extLst>
+          </p:cNvPr>
+          <p:cNvSpPr>
+            <a:spLocks noGrp="1"/>
+          </p:cNvSpPr>
+          <p:nvPr>
+            <p:ph type="title"/>
+          </p:nvPr>
+        </p:nvSpPr>
+        <p:spPr>
+          <a:xfrm>
+            <a:off x="838200" y="365125"/>
+            <a:ext cx="10515600" cy="640080"/>
+          </a:xfrm>
+        </p:spPr>
+        <p:txBody>
+          <a:bodyPr>
+            <a:normAutofit/>
+          </a:bodyPr>
+          <a:lstStyle/>
+          <a:p>
+            <a:pPr algn="ctr"/>
+            <a:r>
+              <a:rPr lang="en-US" sz="3600" dirty="0">
+                <a:latin typeface="Bebas Neue" panose="020B0606020202050201" pitchFamily="34" charset="0"/>
+              </a:rPr>
+              <a:t>Importance of One Hot Encoding</a:t>
+            </a:r>
+          </a:p>
+        </p:txBody>
+      </p:sp>
+      <p:sp>
+        <p:nvSpPr>
+          <p:cNvPr id="3" name="Content Placeholder 2">
+            <a:extLst>
+              <a:ext uri="{FF2B5EF4-FFF2-40B4-BE49-F238E27FC236}">
+                <a16:creationId xmlns:a16="http://schemas.microsoft.com/office/drawing/2014/main" id="{F56ACDEB-9BE6-9E8C-F3F3-47CC1816FE9C}"/>
+              </a:ext>
+            </a:extLst>
+          </p:cNvPr>
+          <p:cNvSpPr>
+            <a:spLocks noGrp="1"/>
+          </p:cNvSpPr>
+          <p:nvPr>
+            <p:ph idx="1"/>
+          </p:nvPr>
+        </p:nvSpPr>
+        <p:spPr>
+          <a:xfrm>
+            <a:off x="838200" y="1091381"/>
+            <a:ext cx="10515600" cy="5085582"/>
+          </a:xfrm>
+        </p:spPr>
+        <p:txBody>
+          <a:bodyPr>
+            <a:normAutofit/>
+          </a:bodyPr>
+          <a:lstStyle/>
+          <a:p>
             <a:pPr marL="457200" indent="-457200" fontAlgn="base">
               <a:buFont typeface="+mj-lt"/>
               <a:buAutoNum type="arabicPeriod" startAt="3"/>
@@ -6425,7 +6777,7 @@
 </p:sld>
 </file>
 
-<file path=ppt/slides/slide4.xml><?xml version="1.0" encoding="utf-8"?>
+<file path=ppt/slides/slide5.xml><?xml version="1.0" encoding="utf-8"?>
 <p:sld xmlns:a="http://schemas.openxmlformats.org/drawingml/2006/main" xmlns:r="http://schemas.openxmlformats.org/officeDocument/2006/relationships" xmlns:p="http://schemas.openxmlformats.org/presentationml/2006/main">
   <p:cSld>
     <p:spTree>
@@ -7099,151 +7451,6 @@
 </p:sld>
 </file>
 
-<file path=ppt/slides/slide5.xml><?xml version="1.0" encoding="utf-8"?>
-<p:sld xmlns:a="http://schemas.openxmlformats.org/drawingml/2006/main" xmlns:r="http://schemas.openxmlformats.org/officeDocument/2006/relationships" xmlns:p="http://schemas.openxmlformats.org/presentationml/2006/main">
-  <p:cSld>
-    <p:spTree>
-      <p:nvGrpSpPr>
-        <p:cNvPr id="1" name="">
-          <a:extLst>
-            <a:ext uri="{FF2B5EF4-FFF2-40B4-BE49-F238E27FC236}">
-              <a16:creationId xmlns:a16="http://schemas.microsoft.com/office/drawing/2014/main" id="{8CA822CF-61E7-D4A4-E048-D296A45421F7}"/>
-            </a:ext>
-          </a:extLst>
-        </p:cNvPr>
-        <p:cNvGrpSpPr/>
-        <p:nvPr/>
-      </p:nvGrpSpPr>
-      <p:grpSpPr>
-        <a:xfrm>
-          <a:off x="0" y="0"/>
-          <a:ext cx="0" cy="0"/>
-          <a:chOff x="0" y="0"/>
-          <a:chExt cx="0" cy="0"/>
-        </a:xfrm>
-      </p:grpSpPr>
-      <p:sp>
-        <p:nvSpPr>
-          <p:cNvPr id="2" name="Title 1">
-            <a:extLst>
-              <a:ext uri="{FF2B5EF4-FFF2-40B4-BE49-F238E27FC236}">
-                <a16:creationId xmlns:a16="http://schemas.microsoft.com/office/drawing/2014/main" id="{B0117384-56C5-24B5-624E-767F3168840B}"/>
-              </a:ext>
-            </a:extLst>
-          </p:cNvPr>
-          <p:cNvSpPr>
-            <a:spLocks noGrp="1"/>
-          </p:cNvSpPr>
-          <p:nvPr>
-            <p:ph type="title"/>
-          </p:nvPr>
-        </p:nvSpPr>
-        <p:spPr>
-          <a:xfrm>
-            <a:off x="838200" y="365125"/>
-            <a:ext cx="10515600" cy="640080"/>
-          </a:xfrm>
-        </p:spPr>
-        <p:txBody>
-          <a:bodyPr>
-            <a:normAutofit/>
-          </a:bodyPr>
-          <a:lstStyle/>
-          <a:p>
-            <a:pPr algn="ctr" fontAlgn="base"/>
-            <a:r>
-              <a:rPr lang="en-US" sz="3600" dirty="0">
-                <a:latin typeface="Bebas Neue" panose="020B0606020202050201" pitchFamily="34" charset="0"/>
-              </a:rPr>
-              <a:t>Advantages of Using One Hot Encoding</a:t>
-            </a:r>
-          </a:p>
-        </p:txBody>
-      </p:sp>
-      <p:sp>
-        <p:nvSpPr>
-          <p:cNvPr id="3" name="Content Placeholder 2">
-            <a:extLst>
-              <a:ext uri="{FF2B5EF4-FFF2-40B4-BE49-F238E27FC236}">
-                <a16:creationId xmlns:a16="http://schemas.microsoft.com/office/drawing/2014/main" id="{F56ACDEB-9BE6-9E8C-F3F3-47CC1816FE9C}"/>
-              </a:ext>
-            </a:extLst>
-          </p:cNvPr>
-          <p:cNvSpPr>
-            <a:spLocks noGrp="1"/>
-          </p:cNvSpPr>
-          <p:nvPr>
-            <p:ph idx="1"/>
-          </p:nvPr>
-        </p:nvSpPr>
-        <p:spPr>
-          <a:xfrm>
-            <a:off x="838200" y="1091381"/>
-            <a:ext cx="10515600" cy="5085582"/>
-          </a:xfrm>
-        </p:spPr>
-        <p:txBody>
-          <a:bodyPr>
-            <a:normAutofit/>
-          </a:bodyPr>
-          <a:lstStyle/>
-          <a:p>
-            <a:pPr marL="342900" indent="-342900" fontAlgn="base">
-              <a:buFont typeface="+mj-lt"/>
-              <a:buAutoNum type="arabicPeriod"/>
-            </a:pPr>
-            <a:r>
-              <a:rPr lang="en-US" sz="2400" dirty="0">
-                <a:latin typeface="Open Sans" pitchFamily="2" charset="0"/>
-                <a:ea typeface="Open Sans" pitchFamily="2" charset="0"/>
-                <a:cs typeface="Open Sans" pitchFamily="2" charset="0"/>
-              </a:rPr>
-              <a:t>It allows the use of categorical variables in models that require numerical input.</a:t>
-            </a:r>
-          </a:p>
-          <a:p>
-            <a:pPr marL="342900" indent="-342900" fontAlgn="base">
-              <a:buFont typeface="+mj-lt"/>
-              <a:buAutoNum type="arabicPeriod"/>
-            </a:pPr>
-            <a:r>
-              <a:rPr lang="en-US" sz="2400" dirty="0">
-                <a:latin typeface="Open Sans" pitchFamily="2" charset="0"/>
-                <a:ea typeface="Open Sans" pitchFamily="2" charset="0"/>
-                <a:cs typeface="Open Sans" pitchFamily="2" charset="0"/>
-              </a:rPr>
-              <a:t>It can improve model performance by providing more information to the model about the categorical variable.</a:t>
-            </a:r>
-          </a:p>
-          <a:p>
-            <a:pPr marL="342900" indent="-342900" fontAlgn="base">
-              <a:buFont typeface="+mj-lt"/>
-              <a:buAutoNum type="arabicPeriod"/>
-            </a:pPr>
-            <a:r>
-              <a:rPr lang="en-US" sz="2400" dirty="0">
-                <a:latin typeface="Open Sans" pitchFamily="2" charset="0"/>
-                <a:ea typeface="Open Sans" pitchFamily="2" charset="0"/>
-                <a:cs typeface="Open Sans" pitchFamily="2" charset="0"/>
-              </a:rPr>
-              <a:t>It can help to avoid the problem of ordinality which can occur when a categorical variable has a natural ordering (e.g. "small", "medium", "large").</a:t>
-            </a:r>
-          </a:p>
-        </p:txBody>
-      </p:sp>
-    </p:spTree>
-    <p:extLst>
-      <p:ext uri="{BB962C8B-B14F-4D97-AF65-F5344CB8AC3E}">
-        <p14:creationId xmlns:p14="http://schemas.microsoft.com/office/powerpoint/2010/main" val="4282224837"/>
-      </p:ext>
-    </p:extLst>
-  </p:cSld>
-  <p:clrMapOvr>
-    <a:masterClrMapping/>
-  </p:clrMapOvr>
-</p:sld>
-</file>
-
 <file path=ppt/slides/slide6.xml><?xml version="1.0" encoding="utf-8"?>
 <p:sld xmlns:a="http://schemas.openxmlformats.org/drawingml/2006/main" xmlns:r="http://schemas.openxmlformats.org/officeDocument/2006/relationships" xmlns:p="http://schemas.openxmlformats.org/presentationml/2006/main">
   <p:cSld>
@@ -7300,7 +7507,7 @@
               <a:rPr lang="en-US" sz="3600" dirty="0">
                 <a:latin typeface="Bebas Neue" panose="020B0606020202050201" pitchFamily="34" charset="0"/>
               </a:rPr>
-              <a:t>Disadvantages of Using One Hot Encoding</a:t>
+              <a:t>Advantages of Using One Hot Encoding</a:t>
             </a:r>
           </a:p>
         </p:txBody>
@@ -7333,7 +7540,7 @@
           </a:bodyPr>
           <a:lstStyle/>
           <a:p>
-            <a:pPr marL="342900" indent="-342900" algn="just" fontAlgn="base">
+            <a:pPr marL="342900" indent="-342900" fontAlgn="base">
               <a:buFont typeface="+mj-lt"/>
               <a:buAutoNum type="arabicPeriod"/>
             </a:pPr>
@@ -7343,11 +7550,11 @@
                 <a:ea typeface="Open Sans" pitchFamily="2" charset="0"/>
                 <a:cs typeface="Open Sans" pitchFamily="2" charset="0"/>
               </a:rPr>
-              <a:t>It can lead to increased dimensionality as a separate column is created for each category in the variable. This can make the model more complex and slower to train.</a:t>
-            </a:r>
-          </a:p>
-          <a:p>
-            <a:pPr marL="342900" indent="-342900" algn="just" fontAlgn="base">
+              <a:t>It allows the use of categorical variables in models that require numerical input.</a:t>
+            </a:r>
+          </a:p>
+          <a:p>
+            <a:pPr marL="342900" indent="-342900" fontAlgn="base">
               <a:buFont typeface="+mj-lt"/>
               <a:buAutoNum type="arabicPeriod"/>
             </a:pPr>
@@ -7357,11 +7564,11 @@
                 <a:ea typeface="Open Sans" pitchFamily="2" charset="0"/>
                 <a:cs typeface="Open Sans" pitchFamily="2" charset="0"/>
               </a:rPr>
-              <a:t>It can lead to sparse data as most observations will have a value of 0 in most of the one-hot encoded columns.</a:t>
-            </a:r>
-          </a:p>
-          <a:p>
-            <a:pPr marL="342900" indent="-342900" algn="just" fontAlgn="base">
+              <a:t>It can improve model performance by providing more information to the model about the categorical variable.</a:t>
+            </a:r>
+          </a:p>
+          <a:p>
+            <a:pPr marL="342900" indent="-342900" fontAlgn="base">
               <a:buFont typeface="+mj-lt"/>
               <a:buAutoNum type="arabicPeriod"/>
             </a:pPr>
@@ -7371,7 +7578,7 @@
                 <a:ea typeface="Open Sans" pitchFamily="2" charset="0"/>
                 <a:cs typeface="Open Sans" pitchFamily="2" charset="0"/>
               </a:rPr>
-              <a:t>It can lead to overfitting especially if there are many categories in the variable and the sample size is relatively small.</a:t>
+              <a:t>It can help to avoid the problem of ordinality which can occur when a categorical variable has a natural ordering (e.g. "small", "medium", "large").</a:t>
             </a:r>
           </a:p>
         </p:txBody>
@@ -7379,7 +7586,7 @@
     </p:spTree>
     <p:extLst>
       <p:ext uri="{BB962C8B-B14F-4D97-AF65-F5344CB8AC3E}">
-        <p14:creationId xmlns:p14="http://schemas.microsoft.com/office/powerpoint/2010/main" val="436713766"/>
+        <p14:creationId xmlns:p14="http://schemas.microsoft.com/office/powerpoint/2010/main" val="4282224837"/>
       </p:ext>
     </p:extLst>
   </p:cSld>
@@ -7440,12 +7647,12 @@
           </a:bodyPr>
           <a:lstStyle/>
           <a:p>
-            <a:pPr algn="ctr"/>
+            <a:pPr algn="ctr" fontAlgn="base"/>
             <a:r>
               <a:rPr lang="en-US" sz="3600" dirty="0">
                 <a:latin typeface="Bebas Neue" panose="020B0606020202050201" pitchFamily="34" charset="0"/>
               </a:rPr>
-              <a:t>Best Practices </a:t>
+              <a:t>Disadvantages of Using One Hot Encoding</a:t>
             </a:r>
           </a:p>
         </p:txBody>
@@ -7478,14 +7685,17 @@
           </a:bodyPr>
           <a:lstStyle/>
           <a:p>
-            <a:pPr algn="just" fontAlgn="base"/>
+            <a:pPr marL="342900" indent="-342900" algn="just" fontAlgn="base">
+              <a:buFont typeface="+mj-lt"/>
+              <a:buAutoNum type="arabicPeriod"/>
+            </a:pPr>
             <a:r>
               <a:rPr lang="en-US" sz="2400" dirty="0">
                 <a:latin typeface="Open Sans" pitchFamily="2" charset="0"/>
                 <a:ea typeface="Open Sans" pitchFamily="2" charset="0"/>
                 <a:cs typeface="Open Sans" pitchFamily="2" charset="0"/>
               </a:rPr>
-              <a:t>To make the most of One Hot Encoding and we must consider the following best practices:</a:t>
+              <a:t>It can lead to increased dimensionality as a separate column is created for each category in the variable. This can make the model more complex and slower to train.</a:t>
             </a:r>
           </a:p>
           <a:p>
@@ -7493,21 +7703,13 @@
               <a:buFont typeface="+mj-lt"/>
               <a:buAutoNum type="arabicPeriod"/>
             </a:pPr>
-            <a:r>
-              <a:rPr lang="en-US" sz="2400" b="1" dirty="0">
-                <a:latin typeface="Open Sans" pitchFamily="2" charset="0"/>
-                <a:ea typeface="Open Sans" pitchFamily="2" charset="0"/>
-                <a:cs typeface="Open Sans" pitchFamily="2" charset="0"/>
-              </a:rPr>
-              <a:t>Limit the Number of Categories</a:t>
-            </a:r>
             <a:r>
               <a:rPr lang="en-US" sz="2400" dirty="0">
                 <a:latin typeface="Open Sans" pitchFamily="2" charset="0"/>
                 <a:ea typeface="Open Sans" pitchFamily="2" charset="0"/>
                 <a:cs typeface="Open Sans" pitchFamily="2" charset="0"/>
               </a:rPr>
-              <a:t>: If you have high cardinality categorical variables consider limiting the number of categories through grouping or feature engineering.</a:t>
+              <a:t>It can lead to sparse data as most observations will have a value of 0 in most of the one-hot encoded columns.</a:t>
             </a:r>
           </a:p>
           <a:p>
@@ -7515,21 +7717,13 @@
               <a:buFont typeface="+mj-lt"/>
               <a:buAutoNum type="arabicPeriod"/>
             </a:pPr>
-            <a:r>
-              <a:rPr lang="en-US" sz="2400" b="1" dirty="0">
-                <a:latin typeface="Open Sans" pitchFamily="2" charset="0"/>
-                <a:ea typeface="Open Sans" pitchFamily="2" charset="0"/>
-                <a:cs typeface="Open Sans" pitchFamily="2" charset="0"/>
-              </a:rPr>
-              <a:t>Use Feature Selection</a:t>
-            </a:r>
             <a:r>
               <a:rPr lang="en-US" sz="2400" dirty="0">
                 <a:latin typeface="Open Sans" pitchFamily="2" charset="0"/>
                 <a:ea typeface="Open Sans" pitchFamily="2" charset="0"/>
                 <a:cs typeface="Open Sans" pitchFamily="2" charset="0"/>
               </a:rPr>
-              <a:t>: Implement feature selection techniques to identify and retain only the most relevant features after One Hot Encoding. This can help reduce dimensionality and improve model performance.</a:t>
+              <a:t>It can lead to overfitting especially if there are many categories in the variable and the sample size is relatively small.</a:t>
             </a:r>
           </a:p>
         </p:txBody>
@@ -7537,7 +7731,7 @@
     </p:spTree>
     <p:extLst>
       <p:ext uri="{BB962C8B-B14F-4D97-AF65-F5344CB8AC3E}">
-        <p14:creationId xmlns:p14="http://schemas.microsoft.com/office/powerpoint/2010/main" val="1396293125"/>
+        <p14:creationId xmlns:p14="http://schemas.microsoft.com/office/powerpoint/2010/main" val="436713766"/>
       </p:ext>
     </p:extLst>
   </p:cSld>
@@ -7636,9 +7830,20 @@
           </a:bodyPr>
           <a:lstStyle/>
           <a:p>
-            <a:pPr marL="457200" indent="-457200" algn="just" fontAlgn="base">
+            <a:pPr algn="just" fontAlgn="base"/>
+            <a:r>
+              <a:rPr lang="en-US" sz="2400" dirty="0">
+                <a:latin typeface="Open Sans" pitchFamily="2" charset="0"/>
+                <a:ea typeface="Open Sans" pitchFamily="2" charset="0"/>
+                <a:cs typeface="Open Sans" pitchFamily="2" charset="0"/>
+              </a:rPr>
+              <a:t>To make the most of One Hot Encoding and we must consider the following best practices:</a:t>
+            </a:r>
+          </a:p>
+          <a:p>
+            <a:pPr marL="342900" indent="-342900" algn="just" fontAlgn="base">
               <a:buFont typeface="+mj-lt"/>
-              <a:buAutoNum type="arabicPeriod" startAt="3"/>
+              <a:buAutoNum type="arabicPeriod"/>
             </a:pPr>
             <a:r>
               <a:rPr lang="en-US" sz="2400" b="1" dirty="0">
@@ -7646,7 +7851,7 @@
                 <a:ea typeface="Open Sans" pitchFamily="2" charset="0"/>
                 <a:cs typeface="Open Sans" pitchFamily="2" charset="0"/>
               </a:rPr>
-              <a:t>Monitor Model Performance</a:t>
+              <a:t>Limit the Number of Categories</a:t>
             </a:r>
             <a:r>
               <a:rPr lang="en-US" sz="2400" dirty="0">
@@ -7654,13 +7859,13 @@
                 <a:ea typeface="Open Sans" pitchFamily="2" charset="0"/>
                 <a:cs typeface="Open Sans" pitchFamily="2" charset="0"/>
               </a:rPr>
-              <a:t>: Regularly evaluate your model's performance after applying One Hot Encoding. If you notice signs of overfitting or other issues consider alternative encoding methods.</a:t>
-            </a:r>
-          </a:p>
-          <a:p>
-            <a:pPr marL="457200" indent="-457200" algn="just" fontAlgn="base">
+              <a:t>: If you have high cardinality categorical variables consider limiting the number of categories through grouping or feature engineering.</a:t>
+            </a:r>
+          </a:p>
+          <a:p>
+            <a:pPr marL="342900" indent="-342900" algn="just" fontAlgn="base">
               <a:buFont typeface="+mj-lt"/>
-              <a:buAutoNum type="arabicPeriod" startAt="3"/>
+              <a:buAutoNum type="arabicPeriod"/>
             </a:pPr>
             <a:r>
               <a:rPr lang="en-US" sz="2400" b="1" dirty="0">
@@ -7668,7 +7873,7 @@
                 <a:ea typeface="Open Sans" pitchFamily="2" charset="0"/>
                 <a:cs typeface="Open Sans" pitchFamily="2" charset="0"/>
               </a:rPr>
-              <a:t>Understand Your Data</a:t>
+              <a:t>Use Feature Selection</a:t>
             </a:r>
             <a:r>
               <a:rPr lang="en-US" sz="2400" dirty="0">
@@ -7676,7 +7881,7 @@
                 <a:ea typeface="Open Sans" pitchFamily="2" charset="0"/>
                 <a:cs typeface="Open Sans" pitchFamily="2" charset="0"/>
               </a:rPr>
-              <a:t>: Before applying One Hot Encoding take the time to understand the nature of your categorical variables. Determine whether they have a natural order and whether One Hot Encoding is appropriate.</a:t>
+              <a:t>: Implement feature selection techniques to identify and retain only the most relevant features after One Hot Encoding. This can help reduce dimensionality and improve model performance.</a:t>
             </a:r>
           </a:p>
         </p:txBody>
@@ -7684,7 +7889,7 @@
     </p:spTree>
     <p:extLst>
       <p:ext uri="{BB962C8B-B14F-4D97-AF65-F5344CB8AC3E}">
-        <p14:creationId xmlns:p14="http://schemas.microsoft.com/office/powerpoint/2010/main" val="1833743390"/>
+        <p14:creationId xmlns:p14="http://schemas.microsoft.com/office/powerpoint/2010/main" val="1396293125"/>
       </p:ext>
     </p:extLst>
   </p:cSld>
@@ -7745,12 +7950,12 @@
           </a:bodyPr>
           <a:lstStyle/>
           <a:p>
-            <a:pPr algn="ctr" fontAlgn="base"/>
+            <a:pPr algn="ctr"/>
             <a:r>
               <a:rPr lang="en-US" sz="3600" dirty="0">
                 <a:latin typeface="Bebas Neue" panose="020B0606020202050201" pitchFamily="34" charset="0"/>
               </a:rPr>
-              <a:t>Alternatives to One Hot Encoding</a:t>
+              <a:t>Best Practices </a:t>
             </a:r>
           </a:p>
         </p:txBody>
@@ -7783,20 +7988,31 @@
           </a:bodyPr>
           <a:lstStyle/>
           <a:p>
-            <a:pPr algn="just" fontAlgn="base"/>
+            <a:pPr marL="457200" indent="-457200" algn="just" fontAlgn="base">
+              <a:buFont typeface="+mj-lt"/>
+              <a:buAutoNum type="arabicPeriod" startAt="3"/>
+            </a:pPr>
+            <a:r>
+              <a:rPr lang="en-US" sz="2400" b="1" dirty="0">
+                <a:latin typeface="Open Sans" pitchFamily="2" charset="0"/>
+                <a:ea typeface="Open Sans" pitchFamily="2" charset="0"/>
+                <a:cs typeface="Open Sans" pitchFamily="2" charset="0"/>
+              </a:rPr>
+              <a:t>Monitor Model Performance</a:t>
+            </a:r>
             <a:r>
               <a:rPr lang="en-US" sz="2400" dirty="0">
                 <a:latin typeface="Open Sans" pitchFamily="2" charset="0"/>
                 <a:ea typeface="Open Sans" pitchFamily="2" charset="0"/>
                 <a:cs typeface="Open Sans" pitchFamily="2" charset="0"/>
               </a:rPr>
-              <a:t>While One Hot Encoding is a popular choice for handling categorical data there are several alternatives that may be more suitable depending on the context:</a:t>
-            </a:r>
-          </a:p>
-          <a:p>
-            <a:pPr marL="342900" indent="-342900" algn="just" fontAlgn="base">
+              <a:t>: Regularly evaluate your model's performance after applying One Hot Encoding. If you notice signs of overfitting or other issues consider alternative encoding methods.</a:t>
+            </a:r>
+          </a:p>
+          <a:p>
+            <a:pPr marL="457200" indent="-457200" algn="just" fontAlgn="base">
               <a:buFont typeface="+mj-lt"/>
-              <a:buAutoNum type="arabicPeriod"/>
+              <a:buAutoNum type="arabicPeriod" startAt="3"/>
             </a:pPr>
             <a:r>
               <a:rPr lang="en-US" sz="2400" b="1" dirty="0">
@@ -7804,7 +8020,7 @@
                 <a:ea typeface="Open Sans" pitchFamily="2" charset="0"/>
                 <a:cs typeface="Open Sans" pitchFamily="2" charset="0"/>
               </a:rPr>
-              <a:t>Label Encoding</a:t>
+              <a:t>Understand Your Data</a:t>
             </a:r>
             <a:r>
               <a:rPr lang="en-US" sz="2400" dirty="0">
@@ -7812,29 +8028,7 @@
                 <a:ea typeface="Open Sans" pitchFamily="2" charset="0"/>
                 <a:cs typeface="Open Sans" pitchFamily="2" charset="0"/>
               </a:rPr>
-              <a:t>: In cases where categorical variables have a natural order (e.g., "Low," "Medium," "High") label encoding can be a better option. This method assigns a unique integer to each category without introducing the same risks of hierarchy misinterpretation as with nominal data.</a:t>
-            </a:r>
-          </a:p>
-          <a:p>
-            <a:pPr marL="342900" indent="-342900" algn="just" fontAlgn="base">
-              <a:buFont typeface="+mj-lt"/>
-              <a:buAutoNum type="arabicPeriod"/>
-            </a:pPr>
-            <a:r>
-              <a:rPr lang="en-US" sz="2400" b="1" dirty="0">
-                <a:latin typeface="Open Sans" pitchFamily="2" charset="0"/>
-                <a:ea typeface="Open Sans" pitchFamily="2" charset="0"/>
-                <a:cs typeface="Open Sans" pitchFamily="2" charset="0"/>
-              </a:rPr>
-              <a:t>Binary Encoding</a:t>
-            </a:r>
-            <a:r>
-              <a:rPr lang="en-US" sz="2400" dirty="0">
-                <a:latin typeface="Open Sans" pitchFamily="2" charset="0"/>
-                <a:ea typeface="Open Sans" pitchFamily="2" charset="0"/>
-                <a:cs typeface="Open Sans" pitchFamily="2" charset="0"/>
-              </a:rPr>
-              <a:t>: This technique combines the benefits of One Hot Encoding and label encoding. It converts categories into binary numbers and then creates binary columns. This method can reduce dimensionality while preserving information.</a:t>
+              <a:t>: Before applying One Hot Encoding take the time to understand the nature of your categorical variables. Determine whether they have a natural order and whether One Hot Encoding is appropriate.</a:t>
             </a:r>
           </a:p>
         </p:txBody>
@@ -7842,7 +8036,7 @@
     </p:spTree>
     <p:extLst>
       <p:ext uri="{BB962C8B-B14F-4D97-AF65-F5344CB8AC3E}">
-        <p14:creationId xmlns:p14="http://schemas.microsoft.com/office/powerpoint/2010/main" val="2595340338"/>
+        <p14:creationId xmlns:p14="http://schemas.microsoft.com/office/powerpoint/2010/main" val="1833743390"/>
       </p:ext>
     </p:extLst>
   </p:cSld>

</xml_diff>